<commit_message>
fix: enforce all four fields required in sheet 2 Co-authored-by: monkeycode-ai <monkeycode-ai@chaitin.com>
</commit_message>
<xml_diff>
--- a/BOM_校验规则详情汇总.pptx
+++ b/BOM_校验规则详情汇总.pptx
@@ -4494,7 +4494,7 @@
               </a:defRPr>
             </a:pPr>
             <a:r>
-              <a:t>  - 工艺路线代码、物料代码系统(固定 CW)、客户代码、业务伙伴物料代码 (全须填写)</a:t>
+              <a:t>  - 工艺路线代码、物料代码系统、客户代码、业务伙伴物料代码 (同填或同空)</a:t>
             </a:r>
           </a:p>
           <a:p>
@@ -4634,7 +4634,7 @@
               </a:defRPr>
             </a:pPr>
             <a:r>
-              <a:t>  - 【豁免规则】若「物料号」包含 WX，则「保质期」不校验必填。</a:t>
+              <a:t>  - 【组校验】工艺代码/系统/客户/伙伴 (4 个)：不能部分填写。如果填了任意一个，四个必须全填。</a:t>
             </a:r>
           </a:p>
           <a:p>
@@ -4646,31 +4646,7 @@
               </a:defRPr>
             </a:pPr>
             <a:r>
-              <a:t>  - 【内部一致】计划数据默认仓库 == 订货数据仓库。</a:t>
-            </a:r>
-          </a:p>
-          <a:p>
-            <a:pPr>
-              <a:defRPr sz="1200">
-                <a:solidFill>
-                  <a:srgbClr val="243B53"/>
-                </a:solidFill>
-              </a:defRPr>
-            </a:pPr>
-            <a:r>
-              <a:t>  - 【内部一致】计划数据计划员 == 订货数据计划员。</a:t>
-            </a:r>
-          </a:p>
-          <a:p>
-            <a:pPr>
-              <a:defRPr sz="1200">
-                <a:solidFill>
-                  <a:srgbClr val="243B53"/>
-                </a:solidFill>
-              </a:defRPr>
-            </a:pPr>
-            <a:r>
-              <a:t>  - 【枚举】单位集: A01。计划员 / 订货计划员: JA153, JA303... 等 7 人。</a:t>
+              <a:t>  - 【枚举】物料代码系统若填，必须为 CW。</a:t>
             </a:r>
           </a:p>
         </p:txBody>

</xml_diff>

<commit_message>
fix: correct duplicate date fields count in sheet 3 and 4 Co-authored-by: monkeycode-ai <monkeycode-ai@chaitin.com>
</commit_message>
<xml_diff>
--- a/BOM_校验规则详情汇总.pptx
+++ b/BOM_校验规则详情汇总.pptx
@@ -4835,7 +4835,7 @@
               </a:defRPr>
             </a:pPr>
             <a:r>
-              <a:t>● 必填字段 (13 项):</a:t>
+              <a:t>● 必填字段 (11 项):</a:t>
             </a:r>
           </a:p>
           <a:p>
@@ -5248,7 +5248,7 @@
               </a:defRPr>
             </a:pPr>
             <a:r>
-              <a:t>● 必填字段 (15 项):</a:t>
+              <a:t>● 必填字段 (13 项):</a:t>
             </a:r>
           </a:p>
           <a:p>

</xml_diff>

<commit_message>
feat: add advanced validation rules (format, self-ref, duplicate process, numeric) and update PPT Co-authored-by: monkeycode-ai <monkeycode-ai@chaitin.com>
</commit_message>
<xml_diff>
--- a/BOM_校验规则详情汇总.pptx
+++ b/BOM_校验规则详情汇总.pptx
@@ -13,6 +13,7 @@
     <p:sldId id="261" r:id="rId12"/>
     <p:sldId id="262" r:id="rId13"/>
     <p:sldId id="263" r:id="rId14"/>
+    <p:sldId id="264" r:id="rId15"/>
   </p:sldIdLst>
   <p:sldSz cx="12191695" cy="6858000" type="screen4x3"/>
   <p:notesSz cx="6858000" cy="9144000"/>
@@ -3296,7 +3297,7 @@
               </a:defRPr>
             </a:pPr>
             <a:r>
-              <a:t>2/8</a:t>
+              <a:t>2/10</a:t>
             </a:r>
           </a:p>
         </p:txBody>
@@ -4007,7 +4008,7 @@
               </a:defRPr>
             </a:pPr>
             <a:r>
-              <a:t>3/8</a:t>
+              <a:t>3/10</a:t>
             </a:r>
           </a:p>
         </p:txBody>
@@ -4384,7 +4385,7 @@
               </a:defRPr>
             </a:pPr>
             <a:r>
-              <a:t>4/8</a:t>
+              <a:t>4/10</a:t>
             </a:r>
           </a:p>
         </p:txBody>
@@ -4797,7 +4798,7 @@
               </a:defRPr>
             </a:pPr>
             <a:r>
-              <a:t>5/8</a:t>
+              <a:t>5/10</a:t>
             </a:r>
           </a:p>
         </p:txBody>
@@ -5210,7 +5211,7 @@
               </a:defRPr>
             </a:pPr>
             <a:r>
-              <a:t>6/8</a:t>
+              <a:t>6/10</a:t>
             </a:r>
           </a:p>
         </p:txBody>
@@ -5596,7 +5597,7 @@
               </a:defRPr>
             </a:pPr>
             <a:r>
-              <a:t>7/8</a:t>
+              <a:t>7/10</a:t>
             </a:r>
           </a:p>
         </p:txBody>
@@ -5970,7 +5971,7 @@
               </a:defRPr>
             </a:pPr>
             <a:r>
-              <a:t>8/8</a:t>
+              <a:t>8/10</a:t>
             </a:r>
           </a:p>
         </p:txBody>
@@ -6280,6 +6281,549 @@
             <a:br/>
             <a:r>
               <a:t>说明：基于电镀速度和步距计算生产周期，仅允许极小误差 (5% 或 0.01 分钟)。</a:t>
+            </a:r>
+          </a:p>
+        </p:txBody>
+      </p:sp>
+    </p:spTree>
+  </p:cSld>
+  <p:clrMapOvr>
+    <a:masterClrMapping/>
+  </p:clrMapOvr>
+</p:sld>
+</file>
+
+<file path=ppt/slides/slide9.xml><?xml version="1.0" encoding="utf-8"?>
+<p:sld xmlns:a="http://schemas.openxmlformats.org/drawingml/2006/main" xmlns:p="http://schemas.openxmlformats.org/presentationml/2006/main" xmlns:r="http://schemas.openxmlformats.org/officeDocument/2006/relationships">
+  <p:cSld>
+    <p:bg>
+      <p:bgPr>
+        <a:solidFill>
+          <a:srgbClr val="FFFFFF"/>
+        </a:solidFill>
+        <a:effectLst/>
+      </p:bgPr>
+    </p:bg>
+    <p:spTree>
+      <p:nvGrpSpPr>
+        <p:cNvPr id="1" name=""/>
+        <p:cNvGrpSpPr/>
+        <p:nvPr/>
+      </p:nvGrpSpPr>
+      <p:grpSpPr/>
+      <p:sp>
+        <p:nvSpPr>
+          <p:cNvPr id="2" name="Rectangle 1"/>
+          <p:cNvSpPr/>
+          <p:nvPr/>
+        </p:nvSpPr>
+        <p:spPr>
+          <a:xfrm>
+            <a:off x="0" y="0"/>
+            <a:ext cx="12191695" cy="1097280"/>
+          </a:xfrm>
+          <a:prstGeom prst="rect">
+            <a:avLst/>
+          </a:prstGeom>
+          <a:solidFill>
+            <a:srgbClr val="102A43"/>
+          </a:solidFill>
+          <a:ln>
+            <a:noFill/>
+          </a:ln>
+        </p:spPr>
+        <p:style>
+          <a:lnRef idx="1">
+            <a:schemeClr val="accent1"/>
+          </a:lnRef>
+          <a:fillRef idx="3">
+            <a:schemeClr val="accent1"/>
+          </a:fillRef>
+          <a:effectRef idx="2">
+            <a:schemeClr val="accent1"/>
+          </a:effectRef>
+          <a:fontRef idx="minor">
+            <a:schemeClr val="lt1"/>
+          </a:fontRef>
+        </p:style>
+        <p:txBody>
+          <a:bodyPr rtlCol="0" anchor="ctr"/>
+          <a:lstStyle/>
+          <a:p>
+            <a:pPr algn="ctr"/>
+          </a:p>
+        </p:txBody>
+      </p:sp>
+      <p:sp>
+        <p:nvSpPr>
+          <p:cNvPr id="3" name="TextBox 2"/>
+          <p:cNvSpPr txBox="1"/>
+          <p:nvPr/>
+        </p:nvSpPr>
+        <p:spPr>
+          <a:xfrm>
+            <a:off x="457200" y="182880"/>
+            <a:ext cx="9144000" cy="822960"/>
+          </a:xfrm>
+          <a:prstGeom prst="rect">
+            <a:avLst/>
+          </a:prstGeom>
+          <a:noFill/>
+        </p:spPr>
+        <p:txBody>
+          <a:bodyPr wrap="square">
+            <a:spAutoFit/>
+          </a:bodyPr>
+          <a:lstStyle/>
+          <a:p>
+            <a:pPr>
+              <a:defRPr sz="2400" b="1">
+                <a:solidFill>
+                  <a:srgbClr val="FFFFFF"/>
+                </a:solidFill>
+              </a:defRPr>
+            </a:pPr>
+            <a:r>
+              <a:t>八、新增数据质量与防呆校验</a:t>
+            </a:r>
+          </a:p>
+          <a:p>
+            <a:pPr>
+              <a:defRPr sz="1400">
+                <a:solidFill>
+                  <a:srgbClr val="88AACC"/>
+                </a:solidFill>
+              </a:defRPr>
+            </a:pPr>
+            <a:r>
+              <a:t>提升数据规范性与系统稳定性的强化规则。</a:t>
+            </a:r>
+          </a:p>
+        </p:txBody>
+      </p:sp>
+      <p:sp>
+        <p:nvSpPr>
+          <p:cNvPr id="4" name="TextBox 3"/>
+          <p:cNvSpPr txBox="1"/>
+          <p:nvPr/>
+        </p:nvSpPr>
+        <p:spPr>
+          <a:xfrm>
+            <a:off x="11430000" y="6400800"/>
+            <a:ext cx="548640" cy="365760"/>
+          </a:xfrm>
+          <a:prstGeom prst="rect">
+            <a:avLst/>
+          </a:prstGeom>
+          <a:noFill/>
+        </p:spPr>
+        <p:txBody>
+          <a:bodyPr wrap="none">
+            <a:spAutoFit/>
+          </a:bodyPr>
+          <a:lstStyle/>
+          <a:p>
+            <a:pPr algn="r">
+              <a:defRPr sz="1000">
+                <a:solidFill>
+                  <a:srgbClr val="8899AA"/>
+                </a:solidFill>
+              </a:defRPr>
+            </a:pPr>
+            <a:r>
+              <a:t>9/10</a:t>
+            </a:r>
+          </a:p>
+        </p:txBody>
+      </p:sp>
+      <p:sp>
+        <p:nvSpPr>
+          <p:cNvPr id="5" name="Rectangle 4"/>
+          <p:cNvSpPr/>
+          <p:nvPr/>
+        </p:nvSpPr>
+        <p:spPr>
+          <a:xfrm>
+            <a:off x="457200" y="1371600"/>
+            <a:ext cx="11247120" cy="1005840"/>
+          </a:xfrm>
+          <a:prstGeom prst="rect">
+            <a:avLst/>
+          </a:prstGeom>
+          <a:solidFill>
+            <a:srgbClr val="F0F4F8"/>
+          </a:solidFill>
+          <a:ln>
+            <a:solidFill>
+              <a:srgbClr val="102A43"/>
+            </a:solidFill>
+          </a:ln>
+        </p:spPr>
+        <p:style>
+          <a:lnRef idx="1">
+            <a:schemeClr val="accent1"/>
+          </a:lnRef>
+          <a:fillRef idx="3">
+            <a:schemeClr val="accent1"/>
+          </a:fillRef>
+          <a:effectRef idx="2">
+            <a:schemeClr val="accent1"/>
+          </a:effectRef>
+          <a:fontRef idx="minor">
+            <a:schemeClr val="lt1"/>
+          </a:fontRef>
+        </p:style>
+        <p:txBody>
+          <a:bodyPr rtlCol="0" anchor="ctr"/>
+          <a:lstStyle/>
+          <a:p>
+            <a:pPr algn="ctr"/>
+          </a:p>
+        </p:txBody>
+      </p:sp>
+      <p:sp>
+        <p:nvSpPr>
+          <p:cNvPr id="6" name="TextBox 5"/>
+          <p:cNvSpPr txBox="1"/>
+          <p:nvPr/>
+        </p:nvSpPr>
+        <p:spPr>
+          <a:xfrm>
+            <a:off x="640080" y="1463040"/>
+            <a:ext cx="10881360" cy="822960"/>
+          </a:xfrm>
+          <a:prstGeom prst="rect">
+            <a:avLst/>
+          </a:prstGeom>
+          <a:noFill/>
+        </p:spPr>
+        <p:txBody>
+          <a:bodyPr wrap="square">
+            <a:spAutoFit/>
+          </a:bodyPr>
+          <a:lstStyle/>
+          <a:p>
+            <a:pPr>
+              <a:defRPr sz="1600" b="1">
+                <a:solidFill>
+                  <a:srgbClr val="102A43"/>
+                </a:solidFill>
+              </a:defRPr>
+            </a:pPr>
+            <a:r>
+              <a:t>1. 关键代码格式净化</a:t>
+            </a:r>
+          </a:p>
+          <a:p>
+            <a:pPr>
+              <a:spcBef>
+                <a:spcPts val="400"/>
+              </a:spcBef>
+              <a:defRPr sz="1300">
+                <a:solidFill>
+                  <a:srgbClr val="243B53"/>
+                </a:solidFill>
+              </a:defRPr>
+            </a:pPr>
+            <a:r>
+              <a:t>工程物料、物料号、制造物料等代码字段禁止包含中文、空格及特殊符号。仅允许：字母、数字、横杠（-）。</a:t>
+            </a:r>
+          </a:p>
+        </p:txBody>
+      </p:sp>
+      <p:sp>
+        <p:nvSpPr>
+          <p:cNvPr id="7" name="Rectangle 6"/>
+          <p:cNvSpPr/>
+          <p:nvPr/>
+        </p:nvSpPr>
+        <p:spPr>
+          <a:xfrm>
+            <a:off x="457200" y="2468880"/>
+            <a:ext cx="11247120" cy="1005840"/>
+          </a:xfrm>
+          <a:prstGeom prst="rect">
+            <a:avLst/>
+          </a:prstGeom>
+          <a:solidFill>
+            <a:srgbClr val="F0F4F8"/>
+          </a:solidFill>
+          <a:ln>
+            <a:solidFill>
+              <a:srgbClr val="102A43"/>
+            </a:solidFill>
+          </a:ln>
+        </p:spPr>
+        <p:style>
+          <a:lnRef idx="1">
+            <a:schemeClr val="accent1"/>
+          </a:lnRef>
+          <a:fillRef idx="3">
+            <a:schemeClr val="accent1"/>
+          </a:fillRef>
+          <a:effectRef idx="2">
+            <a:schemeClr val="accent1"/>
+          </a:effectRef>
+          <a:fontRef idx="minor">
+            <a:schemeClr val="lt1"/>
+          </a:fontRef>
+        </p:style>
+        <p:txBody>
+          <a:bodyPr rtlCol="0" anchor="ctr"/>
+          <a:lstStyle/>
+          <a:p>
+            <a:pPr algn="ctr"/>
+          </a:p>
+        </p:txBody>
+      </p:sp>
+      <p:sp>
+        <p:nvSpPr>
+          <p:cNvPr id="8" name="TextBox 7"/>
+          <p:cNvSpPr txBox="1"/>
+          <p:nvPr/>
+        </p:nvSpPr>
+        <p:spPr>
+          <a:xfrm>
+            <a:off x="640080" y="2560320"/>
+            <a:ext cx="10881360" cy="822960"/>
+          </a:xfrm>
+          <a:prstGeom prst="rect">
+            <a:avLst/>
+          </a:prstGeom>
+          <a:noFill/>
+        </p:spPr>
+        <p:txBody>
+          <a:bodyPr wrap="square">
+            <a:spAutoFit/>
+          </a:bodyPr>
+          <a:lstStyle/>
+          <a:p>
+            <a:pPr>
+              <a:defRPr sz="1600" b="1">
+                <a:solidFill>
+                  <a:srgbClr val="102A43"/>
+                </a:solidFill>
+              </a:defRPr>
+            </a:pPr>
+            <a:r>
+              <a:t>2. 防死循环逻辑 (表三)</a:t>
+            </a:r>
+          </a:p>
+          <a:p>
+            <a:pPr>
+              <a:spcBef>
+                <a:spcPts val="400"/>
+              </a:spcBef>
+              <a:defRPr sz="1300">
+                <a:solidFill>
+                  <a:srgbClr val="243B53"/>
+                </a:solidFill>
+              </a:defRPr>
+            </a:pPr>
+            <a:r>
+              <a:t>BOM 结构中，父级「工程物料」严禁与子级「组件」相同，防止系统展开死循环。</a:t>
+            </a:r>
+          </a:p>
+        </p:txBody>
+      </p:sp>
+      <p:sp>
+        <p:nvSpPr>
+          <p:cNvPr id="9" name="Rectangle 8"/>
+          <p:cNvSpPr/>
+          <p:nvPr/>
+        </p:nvSpPr>
+        <p:spPr>
+          <a:xfrm>
+            <a:off x="457200" y="3566160"/>
+            <a:ext cx="11247120" cy="1005840"/>
+          </a:xfrm>
+          <a:prstGeom prst="rect">
+            <a:avLst/>
+          </a:prstGeom>
+          <a:solidFill>
+            <a:srgbClr val="F0F4F8"/>
+          </a:solidFill>
+          <a:ln>
+            <a:solidFill>
+              <a:srgbClr val="102A43"/>
+            </a:solidFill>
+          </a:ln>
+        </p:spPr>
+        <p:style>
+          <a:lnRef idx="1">
+            <a:schemeClr val="accent1"/>
+          </a:lnRef>
+          <a:fillRef idx="3">
+            <a:schemeClr val="accent1"/>
+          </a:fillRef>
+          <a:effectRef idx="2">
+            <a:schemeClr val="accent1"/>
+          </a:effectRef>
+          <a:fontRef idx="minor">
+            <a:schemeClr val="lt1"/>
+          </a:fontRef>
+        </p:style>
+        <p:txBody>
+          <a:bodyPr rtlCol="0" anchor="ctr"/>
+          <a:lstStyle/>
+          <a:p>
+            <a:pPr algn="ctr"/>
+          </a:p>
+        </p:txBody>
+      </p:sp>
+      <p:sp>
+        <p:nvSpPr>
+          <p:cNvPr id="10" name="TextBox 9"/>
+          <p:cNvSpPr txBox="1"/>
+          <p:nvPr/>
+        </p:nvSpPr>
+        <p:spPr>
+          <a:xfrm>
+            <a:off x="640080" y="3657600"/>
+            <a:ext cx="10881360" cy="822960"/>
+          </a:xfrm>
+          <a:prstGeom prst="rect">
+            <a:avLst/>
+          </a:prstGeom>
+          <a:noFill/>
+        </p:spPr>
+        <p:txBody>
+          <a:bodyPr wrap="square">
+            <a:spAutoFit/>
+          </a:bodyPr>
+          <a:lstStyle/>
+          <a:p>
+            <a:pPr>
+              <a:defRPr sz="1600" b="1">
+                <a:solidFill>
+                  <a:srgbClr val="102A43"/>
+                </a:solidFill>
+              </a:defRPr>
+            </a:pPr>
+            <a:r>
+              <a:t>3. 防重复工序 (表四)</a:t>
+            </a:r>
+          </a:p>
+          <a:p>
+            <a:pPr>
+              <a:spcBef>
+                <a:spcPts val="400"/>
+              </a:spcBef>
+              <a:defRPr sz="1300">
+                <a:solidFill>
+                  <a:srgbClr val="243B53"/>
+                </a:solidFill>
+              </a:defRPr>
+            </a:pPr>
+            <a:r>
+              <a:t>同一个「制造物料」下，不允许存在重复的工序编号，确保工艺路线唯一。</a:t>
+            </a:r>
+          </a:p>
+        </p:txBody>
+      </p:sp>
+      <p:sp>
+        <p:nvSpPr>
+          <p:cNvPr id="11" name="Rectangle 10"/>
+          <p:cNvSpPr/>
+          <p:nvPr/>
+        </p:nvSpPr>
+        <p:spPr>
+          <a:xfrm>
+            <a:off x="457200" y="4663440"/>
+            <a:ext cx="11247120" cy="1005840"/>
+          </a:xfrm>
+          <a:prstGeom prst="rect">
+            <a:avLst/>
+          </a:prstGeom>
+          <a:solidFill>
+            <a:srgbClr val="F0F4F8"/>
+          </a:solidFill>
+          <a:ln>
+            <a:solidFill>
+              <a:srgbClr val="102A43"/>
+            </a:solidFill>
+          </a:ln>
+        </p:spPr>
+        <p:style>
+          <a:lnRef idx="1">
+            <a:schemeClr val="accent1"/>
+          </a:lnRef>
+          <a:fillRef idx="3">
+            <a:schemeClr val="accent1"/>
+          </a:fillRef>
+          <a:effectRef idx="2">
+            <a:schemeClr val="accent1"/>
+          </a:effectRef>
+          <a:fontRef idx="minor">
+            <a:schemeClr val="lt1"/>
+          </a:fontRef>
+        </p:style>
+        <p:txBody>
+          <a:bodyPr rtlCol="0" anchor="ctr"/>
+          <a:lstStyle/>
+          <a:p>
+            <a:pPr algn="ctr"/>
+          </a:p>
+        </p:txBody>
+      </p:sp>
+      <p:sp>
+        <p:nvSpPr>
+          <p:cNvPr id="12" name="TextBox 11"/>
+          <p:cNvSpPr txBox="1"/>
+          <p:nvPr/>
+        </p:nvSpPr>
+        <p:spPr>
+          <a:xfrm>
+            <a:off x="640080" y="4754880"/>
+            <a:ext cx="10881360" cy="822960"/>
+          </a:xfrm>
+          <a:prstGeom prst="rect">
+            <a:avLst/>
+          </a:prstGeom>
+          <a:noFill/>
+        </p:spPr>
+        <p:txBody>
+          <a:bodyPr wrap="square">
+            <a:spAutoFit/>
+          </a:bodyPr>
+          <a:lstStyle/>
+          <a:p>
+            <a:pPr>
+              <a:defRPr sz="1600" b="1">
+                <a:solidFill>
+                  <a:srgbClr val="102A43"/>
+                </a:solidFill>
+              </a:defRPr>
+            </a:pPr>
+            <a:r>
+              <a:t>4. 核心数值范围</a:t>
+            </a:r>
+          </a:p>
+          <a:p>
+            <a:pPr>
+              <a:spcBef>
+                <a:spcPts val="400"/>
+              </a:spcBef>
+              <a:defRPr sz="1300">
+                <a:solidFill>
+                  <a:srgbClr val="243B53"/>
+                </a:solidFill>
+              </a:defRPr>
+            </a:pPr>
+            <a:r>
+              <a:t>• 净数量、SPM、生产周期：必须 &gt; 0。</a:t>
+            </a:r>
+            <a:br/>
+            <a:r>
+              <a:t>• 废品率、重量类字段：不能 &lt; 0。</a:t>
+            </a:r>
+            <a:br/>
+            <a:r>
+              <a:t>• 模穴数：必须为正整数。</a:t>
+            </a:r>
+            <a:br/>
+            <a:r>
+              <a:t>• 回料百分比：必须在 0-100 之间。</a:t>
             </a:r>
           </a:p>
         </p:txBody>

</xml_diff>

<commit_message>
fix: allow special symbols in key fields and update PPT Co-authored-by: monkeycode-ai <monkeycode-ai@chaitin.com>
</commit_message>
<xml_diff>
--- a/BOM_校验规则详情汇总.pptx
+++ b/BOM_校验规则详情汇总.pptx
@@ -6511,7 +6511,7 @@
               </a:defRPr>
             </a:pPr>
             <a:r>
-              <a:t>1. 关键代码格式净化</a:t>
+              <a:t>1. 防死循环逻辑 (表三)</a:t>
             </a:r>
           </a:p>
           <a:p>
@@ -6526,7 +6526,7 @@
               </a:defRPr>
             </a:pPr>
             <a:r>
-              <a:t>工程物料、物料号、制造物料等代码字段禁止包含中文、空格及特殊符号。仅允许：字母、数字、横杠（-）。</a:t>
+              <a:t>BOM 结构中，父级「工程物料」严禁与子级「组件」相同，防止系统展开死循环。</a:t>
             </a:r>
           </a:p>
         </p:txBody>
@@ -6606,7 +6606,7 @@
               </a:defRPr>
             </a:pPr>
             <a:r>
-              <a:t>2. 防死循环逻辑 (表三)</a:t>
+              <a:t>2. 防重复工序 (表四)</a:t>
             </a:r>
           </a:p>
           <a:p>
@@ -6621,7 +6621,7 @@
               </a:defRPr>
             </a:pPr>
             <a:r>
-              <a:t>BOM 结构中，父级「工程物料」严禁与子级「组件」相同，防止系统展开死循环。</a:t>
+              <a:t>同一个「制造物料」下，不允许存在重复的工序编号，确保工艺路线唯一。</a:t>
             </a:r>
           </a:p>
         </p:txBody>
@@ -6701,102 +6701,7 @@
               </a:defRPr>
             </a:pPr>
             <a:r>
-              <a:t>3. 防重复工序 (表四)</a:t>
-            </a:r>
-          </a:p>
-          <a:p>
-            <a:pPr>
-              <a:spcBef>
-                <a:spcPts val="400"/>
-              </a:spcBef>
-              <a:defRPr sz="1300">
-                <a:solidFill>
-                  <a:srgbClr val="243B53"/>
-                </a:solidFill>
-              </a:defRPr>
-            </a:pPr>
-            <a:r>
-              <a:t>同一个「制造物料」下，不允许存在重复的工序编号，确保工艺路线唯一。</a:t>
-            </a:r>
-          </a:p>
-        </p:txBody>
-      </p:sp>
-      <p:sp>
-        <p:nvSpPr>
-          <p:cNvPr id="11" name="Rectangle 10"/>
-          <p:cNvSpPr/>
-          <p:nvPr/>
-        </p:nvSpPr>
-        <p:spPr>
-          <a:xfrm>
-            <a:off x="457200" y="4663440"/>
-            <a:ext cx="11247120" cy="1005840"/>
-          </a:xfrm>
-          <a:prstGeom prst="rect">
-            <a:avLst/>
-          </a:prstGeom>
-          <a:solidFill>
-            <a:srgbClr val="F0F4F8"/>
-          </a:solidFill>
-          <a:ln>
-            <a:solidFill>
-              <a:srgbClr val="102A43"/>
-            </a:solidFill>
-          </a:ln>
-        </p:spPr>
-        <p:style>
-          <a:lnRef idx="1">
-            <a:schemeClr val="accent1"/>
-          </a:lnRef>
-          <a:fillRef idx="3">
-            <a:schemeClr val="accent1"/>
-          </a:fillRef>
-          <a:effectRef idx="2">
-            <a:schemeClr val="accent1"/>
-          </a:effectRef>
-          <a:fontRef idx="minor">
-            <a:schemeClr val="lt1"/>
-          </a:fontRef>
-        </p:style>
-        <p:txBody>
-          <a:bodyPr rtlCol="0" anchor="ctr"/>
-          <a:lstStyle/>
-          <a:p>
-            <a:pPr algn="ctr"/>
-          </a:p>
-        </p:txBody>
-      </p:sp>
-      <p:sp>
-        <p:nvSpPr>
-          <p:cNvPr id="12" name="TextBox 11"/>
-          <p:cNvSpPr txBox="1"/>
-          <p:nvPr/>
-        </p:nvSpPr>
-        <p:spPr>
-          <a:xfrm>
-            <a:off x="640080" y="4754880"/>
-            <a:ext cx="10881360" cy="822960"/>
-          </a:xfrm>
-          <a:prstGeom prst="rect">
-            <a:avLst/>
-          </a:prstGeom>
-          <a:noFill/>
-        </p:spPr>
-        <p:txBody>
-          <a:bodyPr wrap="square">
-            <a:spAutoFit/>
-          </a:bodyPr>
-          <a:lstStyle/>
-          <a:p>
-            <a:pPr>
-              <a:defRPr sz="1600" b="1">
-                <a:solidFill>
-                  <a:srgbClr val="102A43"/>
-                </a:solidFill>
-              </a:defRPr>
-            </a:pPr>
-            <a:r>
-              <a:t>4. 核心数值范围</a:t>
+              <a:t>3. 核心数值范围</a:t>
             </a:r>
           </a:p>
           <a:p>

</xml_diff>

<commit_message>
revert: remove advanced validation rules (data quality, fool-proofing) Co-authored-by: monkeycode-ai <monkeycode-ai@chaitin.com>
</commit_message>
<xml_diff>
--- a/BOM_校验规则详情汇总.pptx
+++ b/BOM_校验规则详情汇总.pptx
@@ -13,7 +13,6 @@
     <p:sldId id="261" r:id="rId12"/>
     <p:sldId id="262" r:id="rId13"/>
     <p:sldId id="263" r:id="rId14"/>
-    <p:sldId id="264" r:id="rId15"/>
   </p:sldIdLst>
   <p:sldSz cx="12191695" cy="6858000" type="screen4x3"/>
   <p:notesSz cx="6858000" cy="9144000"/>
@@ -3297,7 +3296,7 @@
               </a:defRPr>
             </a:pPr>
             <a:r>
-              <a:t>2/10</a:t>
+              <a:t>2/9</a:t>
             </a:r>
           </a:p>
         </p:txBody>
@@ -4008,7 +4007,7 @@
               </a:defRPr>
             </a:pPr>
             <a:r>
-              <a:t>3/10</a:t>
+              <a:t>3/9</a:t>
             </a:r>
           </a:p>
         </p:txBody>
@@ -4385,7 +4384,7 @@
               </a:defRPr>
             </a:pPr>
             <a:r>
-              <a:t>4/10</a:t>
+              <a:t>4/9</a:t>
             </a:r>
           </a:p>
         </p:txBody>
@@ -4798,7 +4797,7 @@
               </a:defRPr>
             </a:pPr>
             <a:r>
-              <a:t>5/10</a:t>
+              <a:t>5/9</a:t>
             </a:r>
           </a:p>
         </p:txBody>
@@ -5211,7 +5210,7 @@
               </a:defRPr>
             </a:pPr>
             <a:r>
-              <a:t>6/10</a:t>
+              <a:t>6/9</a:t>
             </a:r>
           </a:p>
         </p:txBody>
@@ -5597,7 +5596,7 @@
               </a:defRPr>
             </a:pPr>
             <a:r>
-              <a:t>7/10</a:t>
+              <a:t>7/9</a:t>
             </a:r>
           </a:p>
         </p:txBody>
@@ -5971,7 +5970,7 @@
               </a:defRPr>
             </a:pPr>
             <a:r>
-              <a:t>8/10</a:t>
+              <a:t>8/9</a:t>
             </a:r>
           </a:p>
         </p:txBody>
@@ -6281,454 +6280,6 @@
             <a:br/>
             <a:r>
               <a:t>说明：基于电镀速度和步距计算生产周期，仅允许极小误差 (5% 或 0.01 分钟)。</a:t>
-            </a:r>
-          </a:p>
-        </p:txBody>
-      </p:sp>
-    </p:spTree>
-  </p:cSld>
-  <p:clrMapOvr>
-    <a:masterClrMapping/>
-  </p:clrMapOvr>
-</p:sld>
-</file>
-
-<file path=ppt/slides/slide9.xml><?xml version="1.0" encoding="utf-8"?>
-<p:sld xmlns:a="http://schemas.openxmlformats.org/drawingml/2006/main" xmlns:p="http://schemas.openxmlformats.org/presentationml/2006/main" xmlns:r="http://schemas.openxmlformats.org/officeDocument/2006/relationships">
-  <p:cSld>
-    <p:bg>
-      <p:bgPr>
-        <a:solidFill>
-          <a:srgbClr val="FFFFFF"/>
-        </a:solidFill>
-        <a:effectLst/>
-      </p:bgPr>
-    </p:bg>
-    <p:spTree>
-      <p:nvGrpSpPr>
-        <p:cNvPr id="1" name=""/>
-        <p:cNvGrpSpPr/>
-        <p:nvPr/>
-      </p:nvGrpSpPr>
-      <p:grpSpPr/>
-      <p:sp>
-        <p:nvSpPr>
-          <p:cNvPr id="2" name="Rectangle 1"/>
-          <p:cNvSpPr/>
-          <p:nvPr/>
-        </p:nvSpPr>
-        <p:spPr>
-          <a:xfrm>
-            <a:off x="0" y="0"/>
-            <a:ext cx="12191695" cy="1097280"/>
-          </a:xfrm>
-          <a:prstGeom prst="rect">
-            <a:avLst/>
-          </a:prstGeom>
-          <a:solidFill>
-            <a:srgbClr val="102A43"/>
-          </a:solidFill>
-          <a:ln>
-            <a:noFill/>
-          </a:ln>
-        </p:spPr>
-        <p:style>
-          <a:lnRef idx="1">
-            <a:schemeClr val="accent1"/>
-          </a:lnRef>
-          <a:fillRef idx="3">
-            <a:schemeClr val="accent1"/>
-          </a:fillRef>
-          <a:effectRef idx="2">
-            <a:schemeClr val="accent1"/>
-          </a:effectRef>
-          <a:fontRef idx="minor">
-            <a:schemeClr val="lt1"/>
-          </a:fontRef>
-        </p:style>
-        <p:txBody>
-          <a:bodyPr rtlCol="0" anchor="ctr"/>
-          <a:lstStyle/>
-          <a:p>
-            <a:pPr algn="ctr"/>
-          </a:p>
-        </p:txBody>
-      </p:sp>
-      <p:sp>
-        <p:nvSpPr>
-          <p:cNvPr id="3" name="TextBox 2"/>
-          <p:cNvSpPr txBox="1"/>
-          <p:nvPr/>
-        </p:nvSpPr>
-        <p:spPr>
-          <a:xfrm>
-            <a:off x="457200" y="182880"/>
-            <a:ext cx="9144000" cy="822960"/>
-          </a:xfrm>
-          <a:prstGeom prst="rect">
-            <a:avLst/>
-          </a:prstGeom>
-          <a:noFill/>
-        </p:spPr>
-        <p:txBody>
-          <a:bodyPr wrap="square">
-            <a:spAutoFit/>
-          </a:bodyPr>
-          <a:lstStyle/>
-          <a:p>
-            <a:pPr>
-              <a:defRPr sz="2400" b="1">
-                <a:solidFill>
-                  <a:srgbClr val="FFFFFF"/>
-                </a:solidFill>
-              </a:defRPr>
-            </a:pPr>
-            <a:r>
-              <a:t>八、新增数据质量与防呆校验</a:t>
-            </a:r>
-          </a:p>
-          <a:p>
-            <a:pPr>
-              <a:defRPr sz="1400">
-                <a:solidFill>
-                  <a:srgbClr val="88AACC"/>
-                </a:solidFill>
-              </a:defRPr>
-            </a:pPr>
-            <a:r>
-              <a:t>提升数据规范性与系统稳定性的强化规则。</a:t>
-            </a:r>
-          </a:p>
-        </p:txBody>
-      </p:sp>
-      <p:sp>
-        <p:nvSpPr>
-          <p:cNvPr id="4" name="TextBox 3"/>
-          <p:cNvSpPr txBox="1"/>
-          <p:nvPr/>
-        </p:nvSpPr>
-        <p:spPr>
-          <a:xfrm>
-            <a:off x="11430000" y="6400800"/>
-            <a:ext cx="548640" cy="365760"/>
-          </a:xfrm>
-          <a:prstGeom prst="rect">
-            <a:avLst/>
-          </a:prstGeom>
-          <a:noFill/>
-        </p:spPr>
-        <p:txBody>
-          <a:bodyPr wrap="none">
-            <a:spAutoFit/>
-          </a:bodyPr>
-          <a:lstStyle/>
-          <a:p>
-            <a:pPr algn="r">
-              <a:defRPr sz="1000">
-                <a:solidFill>
-                  <a:srgbClr val="8899AA"/>
-                </a:solidFill>
-              </a:defRPr>
-            </a:pPr>
-            <a:r>
-              <a:t>9/10</a:t>
-            </a:r>
-          </a:p>
-        </p:txBody>
-      </p:sp>
-      <p:sp>
-        <p:nvSpPr>
-          <p:cNvPr id="5" name="Rectangle 4"/>
-          <p:cNvSpPr/>
-          <p:nvPr/>
-        </p:nvSpPr>
-        <p:spPr>
-          <a:xfrm>
-            <a:off x="457200" y="1371600"/>
-            <a:ext cx="11247120" cy="1005840"/>
-          </a:xfrm>
-          <a:prstGeom prst="rect">
-            <a:avLst/>
-          </a:prstGeom>
-          <a:solidFill>
-            <a:srgbClr val="F0F4F8"/>
-          </a:solidFill>
-          <a:ln>
-            <a:solidFill>
-              <a:srgbClr val="102A43"/>
-            </a:solidFill>
-          </a:ln>
-        </p:spPr>
-        <p:style>
-          <a:lnRef idx="1">
-            <a:schemeClr val="accent1"/>
-          </a:lnRef>
-          <a:fillRef idx="3">
-            <a:schemeClr val="accent1"/>
-          </a:fillRef>
-          <a:effectRef idx="2">
-            <a:schemeClr val="accent1"/>
-          </a:effectRef>
-          <a:fontRef idx="minor">
-            <a:schemeClr val="lt1"/>
-          </a:fontRef>
-        </p:style>
-        <p:txBody>
-          <a:bodyPr rtlCol="0" anchor="ctr"/>
-          <a:lstStyle/>
-          <a:p>
-            <a:pPr algn="ctr"/>
-          </a:p>
-        </p:txBody>
-      </p:sp>
-      <p:sp>
-        <p:nvSpPr>
-          <p:cNvPr id="6" name="TextBox 5"/>
-          <p:cNvSpPr txBox="1"/>
-          <p:nvPr/>
-        </p:nvSpPr>
-        <p:spPr>
-          <a:xfrm>
-            <a:off x="640080" y="1463040"/>
-            <a:ext cx="10881360" cy="822960"/>
-          </a:xfrm>
-          <a:prstGeom prst="rect">
-            <a:avLst/>
-          </a:prstGeom>
-          <a:noFill/>
-        </p:spPr>
-        <p:txBody>
-          <a:bodyPr wrap="square">
-            <a:spAutoFit/>
-          </a:bodyPr>
-          <a:lstStyle/>
-          <a:p>
-            <a:pPr>
-              <a:defRPr sz="1600" b="1">
-                <a:solidFill>
-                  <a:srgbClr val="102A43"/>
-                </a:solidFill>
-              </a:defRPr>
-            </a:pPr>
-            <a:r>
-              <a:t>1. 防死循环逻辑 (表三)</a:t>
-            </a:r>
-          </a:p>
-          <a:p>
-            <a:pPr>
-              <a:spcBef>
-                <a:spcPts val="400"/>
-              </a:spcBef>
-              <a:defRPr sz="1300">
-                <a:solidFill>
-                  <a:srgbClr val="243B53"/>
-                </a:solidFill>
-              </a:defRPr>
-            </a:pPr>
-            <a:r>
-              <a:t>BOM 结构中，父级「工程物料」严禁与子级「组件」相同，防止系统展开死循环。</a:t>
-            </a:r>
-          </a:p>
-        </p:txBody>
-      </p:sp>
-      <p:sp>
-        <p:nvSpPr>
-          <p:cNvPr id="7" name="Rectangle 6"/>
-          <p:cNvSpPr/>
-          <p:nvPr/>
-        </p:nvSpPr>
-        <p:spPr>
-          <a:xfrm>
-            <a:off x="457200" y="2468880"/>
-            <a:ext cx="11247120" cy="1005840"/>
-          </a:xfrm>
-          <a:prstGeom prst="rect">
-            <a:avLst/>
-          </a:prstGeom>
-          <a:solidFill>
-            <a:srgbClr val="F0F4F8"/>
-          </a:solidFill>
-          <a:ln>
-            <a:solidFill>
-              <a:srgbClr val="102A43"/>
-            </a:solidFill>
-          </a:ln>
-        </p:spPr>
-        <p:style>
-          <a:lnRef idx="1">
-            <a:schemeClr val="accent1"/>
-          </a:lnRef>
-          <a:fillRef idx="3">
-            <a:schemeClr val="accent1"/>
-          </a:fillRef>
-          <a:effectRef idx="2">
-            <a:schemeClr val="accent1"/>
-          </a:effectRef>
-          <a:fontRef idx="minor">
-            <a:schemeClr val="lt1"/>
-          </a:fontRef>
-        </p:style>
-        <p:txBody>
-          <a:bodyPr rtlCol="0" anchor="ctr"/>
-          <a:lstStyle/>
-          <a:p>
-            <a:pPr algn="ctr"/>
-          </a:p>
-        </p:txBody>
-      </p:sp>
-      <p:sp>
-        <p:nvSpPr>
-          <p:cNvPr id="8" name="TextBox 7"/>
-          <p:cNvSpPr txBox="1"/>
-          <p:nvPr/>
-        </p:nvSpPr>
-        <p:spPr>
-          <a:xfrm>
-            <a:off x="640080" y="2560320"/>
-            <a:ext cx="10881360" cy="822960"/>
-          </a:xfrm>
-          <a:prstGeom prst="rect">
-            <a:avLst/>
-          </a:prstGeom>
-          <a:noFill/>
-        </p:spPr>
-        <p:txBody>
-          <a:bodyPr wrap="square">
-            <a:spAutoFit/>
-          </a:bodyPr>
-          <a:lstStyle/>
-          <a:p>
-            <a:pPr>
-              <a:defRPr sz="1600" b="1">
-                <a:solidFill>
-                  <a:srgbClr val="102A43"/>
-                </a:solidFill>
-              </a:defRPr>
-            </a:pPr>
-            <a:r>
-              <a:t>2. 防重复工序 (表四)</a:t>
-            </a:r>
-          </a:p>
-          <a:p>
-            <a:pPr>
-              <a:spcBef>
-                <a:spcPts val="400"/>
-              </a:spcBef>
-              <a:defRPr sz="1300">
-                <a:solidFill>
-                  <a:srgbClr val="243B53"/>
-                </a:solidFill>
-              </a:defRPr>
-            </a:pPr>
-            <a:r>
-              <a:t>同一个「制造物料」下，不允许存在重复的工序编号，确保工艺路线唯一。</a:t>
-            </a:r>
-          </a:p>
-        </p:txBody>
-      </p:sp>
-      <p:sp>
-        <p:nvSpPr>
-          <p:cNvPr id="9" name="Rectangle 8"/>
-          <p:cNvSpPr/>
-          <p:nvPr/>
-        </p:nvSpPr>
-        <p:spPr>
-          <a:xfrm>
-            <a:off x="457200" y="3566160"/>
-            <a:ext cx="11247120" cy="1005840"/>
-          </a:xfrm>
-          <a:prstGeom prst="rect">
-            <a:avLst/>
-          </a:prstGeom>
-          <a:solidFill>
-            <a:srgbClr val="F0F4F8"/>
-          </a:solidFill>
-          <a:ln>
-            <a:solidFill>
-              <a:srgbClr val="102A43"/>
-            </a:solidFill>
-          </a:ln>
-        </p:spPr>
-        <p:style>
-          <a:lnRef idx="1">
-            <a:schemeClr val="accent1"/>
-          </a:lnRef>
-          <a:fillRef idx="3">
-            <a:schemeClr val="accent1"/>
-          </a:fillRef>
-          <a:effectRef idx="2">
-            <a:schemeClr val="accent1"/>
-          </a:effectRef>
-          <a:fontRef idx="minor">
-            <a:schemeClr val="lt1"/>
-          </a:fontRef>
-        </p:style>
-        <p:txBody>
-          <a:bodyPr rtlCol="0" anchor="ctr"/>
-          <a:lstStyle/>
-          <a:p>
-            <a:pPr algn="ctr"/>
-          </a:p>
-        </p:txBody>
-      </p:sp>
-      <p:sp>
-        <p:nvSpPr>
-          <p:cNvPr id="10" name="TextBox 9"/>
-          <p:cNvSpPr txBox="1"/>
-          <p:nvPr/>
-        </p:nvSpPr>
-        <p:spPr>
-          <a:xfrm>
-            <a:off x="640080" y="3657600"/>
-            <a:ext cx="10881360" cy="822960"/>
-          </a:xfrm>
-          <a:prstGeom prst="rect">
-            <a:avLst/>
-          </a:prstGeom>
-          <a:noFill/>
-        </p:spPr>
-        <p:txBody>
-          <a:bodyPr wrap="square">
-            <a:spAutoFit/>
-          </a:bodyPr>
-          <a:lstStyle/>
-          <a:p>
-            <a:pPr>
-              <a:defRPr sz="1600" b="1">
-                <a:solidFill>
-                  <a:srgbClr val="102A43"/>
-                </a:solidFill>
-              </a:defRPr>
-            </a:pPr>
-            <a:r>
-              <a:t>3. 核心数值范围</a:t>
-            </a:r>
-          </a:p>
-          <a:p>
-            <a:pPr>
-              <a:spcBef>
-                <a:spcPts val="400"/>
-              </a:spcBef>
-              <a:defRPr sz="1300">
-                <a:solidFill>
-                  <a:srgbClr val="243B53"/>
-                </a:solidFill>
-              </a:defRPr>
-            </a:pPr>
-            <a:r>
-              <a:t>• 净数量、SPM、生产周期：必须 &gt; 0。</a:t>
-            </a:r>
-            <a:br/>
-            <a:r>
-              <a:t>• 废品率、重量类字段：不能 &lt; 0。</a:t>
-            </a:r>
-            <a:br/>
-            <a:r>
-              <a:t>• 模穴数：必须为正整数。</a:t>
-            </a:r>
-            <a:br/>
-            <a:r>
-              <a:t>• 回料百分比：必须在 0-100 之间。</a:t>
             </a:r>
           </a:p>
         </p:txBody>

</xml_diff>

<commit_message>
feat: add industrial validation rules (dead loop, specific qty logic, duplicate ops) Co-authored-by: monkeycode-ai <monkeycode-ai@chaitin.com>
</commit_message>
<xml_diff>
--- a/BOM_校验规则详情汇总.pptx
+++ b/BOM_校验规则详情汇总.pptx
@@ -13,6 +13,7 @@
     <p:sldId id="261" r:id="rId12"/>
     <p:sldId id="262" r:id="rId13"/>
     <p:sldId id="263" r:id="rId14"/>
+    <p:sldId id="264" r:id="rId15"/>
   </p:sldIdLst>
   <p:sldSz cx="12191695" cy="6858000" type="screen4x3"/>
   <p:notesSz cx="6858000" cy="9144000"/>
@@ -6280,6 +6281,648 @@
             <a:br/>
             <a:r>
               <a:t>说明：基于电镀速度和步距计算生产周期，仅允许极小误差 (5% 或 0.01 分钟)。</a:t>
+            </a:r>
+          </a:p>
+        </p:txBody>
+      </p:sp>
+    </p:spTree>
+  </p:cSld>
+  <p:clrMapOvr>
+    <a:masterClrMapping/>
+  </p:clrMapOvr>
+</p:sld>
+</file>
+
+<file path=ppt/slides/slide9.xml><?xml version="1.0" encoding="utf-8"?>
+<p:sld xmlns:a="http://schemas.openxmlformats.org/drawingml/2006/main" xmlns:p="http://schemas.openxmlformats.org/presentationml/2006/main" xmlns:r="http://schemas.openxmlformats.org/officeDocument/2006/relationships">
+  <p:cSld>
+    <p:bg>
+      <p:bgPr>
+        <a:solidFill>
+          <a:srgbClr val="FFFFFF"/>
+        </a:solidFill>
+        <a:effectLst/>
+      </p:bgPr>
+    </p:bg>
+    <p:spTree>
+      <p:nvGrpSpPr>
+        <p:cNvPr id="1" name=""/>
+        <p:cNvGrpSpPr/>
+        <p:nvPr/>
+      </p:nvGrpSpPr>
+      <p:grpSpPr/>
+      <p:sp>
+        <p:nvSpPr>
+          <p:cNvPr id="2" name="Rectangle 1"/>
+          <p:cNvSpPr/>
+          <p:nvPr/>
+        </p:nvSpPr>
+        <p:spPr>
+          <a:xfrm>
+            <a:off x="0" y="0"/>
+            <a:ext cx="12191695" cy="1097280"/>
+          </a:xfrm>
+          <a:prstGeom prst="rect">
+            <a:avLst/>
+          </a:prstGeom>
+          <a:solidFill>
+            <a:srgbClr val="102A43"/>
+          </a:solidFill>
+          <a:ln>
+            <a:noFill/>
+          </a:ln>
+        </p:spPr>
+        <p:style>
+          <a:lnRef idx="1">
+            <a:schemeClr val="accent1"/>
+          </a:lnRef>
+          <a:fillRef idx="3">
+            <a:schemeClr val="accent1"/>
+          </a:fillRef>
+          <a:effectRef idx="2">
+            <a:schemeClr val="accent1"/>
+          </a:effectRef>
+          <a:fontRef idx="minor">
+            <a:schemeClr val="lt1"/>
+          </a:fontRef>
+        </p:style>
+        <p:txBody>
+          <a:bodyPr rtlCol="0" anchor="ctr"/>
+          <a:lstStyle/>
+          <a:p>
+            <a:pPr algn="ctr"/>
+          </a:p>
+        </p:txBody>
+      </p:sp>
+      <p:sp>
+        <p:nvSpPr>
+          <p:cNvPr id="3" name="TextBox 2"/>
+          <p:cNvSpPr txBox="1"/>
+          <p:nvPr/>
+        </p:nvSpPr>
+        <p:spPr>
+          <a:xfrm>
+            <a:off x="457200" y="182880"/>
+            <a:ext cx="9144000" cy="822960"/>
+          </a:xfrm>
+          <a:prstGeom prst="rect">
+            <a:avLst/>
+          </a:prstGeom>
+          <a:noFill/>
+        </p:spPr>
+        <p:txBody>
+          <a:bodyPr wrap="square">
+            <a:spAutoFit/>
+          </a:bodyPr>
+          <a:lstStyle/>
+          <a:p>
+            <a:pPr>
+              <a:defRPr sz="2400" b="1">
+                <a:solidFill>
+                  <a:srgbClr val="FFFFFF"/>
+                </a:solidFill>
+              </a:defRPr>
+            </a:pPr>
+            <a:r>
+              <a:t>八、新增数据质量与防呆校验</a:t>
+            </a:r>
+          </a:p>
+          <a:p>
+            <a:pPr>
+              <a:defRPr sz="1400">
+                <a:solidFill>
+                  <a:srgbClr val="88AACC"/>
+                </a:solidFill>
+              </a:defRPr>
+            </a:pPr>
+            <a:r>
+              <a:t>提升数据规范性与系统稳定性的强化规则。</a:t>
+            </a:r>
+          </a:p>
+        </p:txBody>
+      </p:sp>
+      <p:sp>
+        <p:nvSpPr>
+          <p:cNvPr id="4" name="TextBox 3"/>
+          <p:cNvSpPr txBox="1"/>
+          <p:nvPr/>
+        </p:nvSpPr>
+        <p:spPr>
+          <a:xfrm>
+            <a:off x="11430000" y="6400800"/>
+            <a:ext cx="548640" cy="365760"/>
+          </a:xfrm>
+          <a:prstGeom prst="rect">
+            <a:avLst/>
+          </a:prstGeom>
+          <a:noFill/>
+        </p:spPr>
+        <p:txBody>
+          <a:bodyPr wrap="none">
+            <a:spAutoFit/>
+          </a:bodyPr>
+          <a:lstStyle/>
+          <a:p>
+            <a:pPr algn="r">
+              <a:defRPr sz="1000">
+                <a:solidFill>
+                  <a:srgbClr val="8899AA"/>
+                </a:solidFill>
+              </a:defRPr>
+            </a:pPr>
+            <a:r>
+              <a:t>9/9</a:t>
+            </a:r>
+          </a:p>
+        </p:txBody>
+      </p:sp>
+      <p:sp>
+        <p:nvSpPr>
+          <p:cNvPr id="5" name="Rectangle 4"/>
+          <p:cNvSpPr/>
+          <p:nvPr/>
+        </p:nvSpPr>
+        <p:spPr>
+          <a:xfrm>
+            <a:off x="457200" y="1371600"/>
+            <a:ext cx="11247120" cy="868680"/>
+          </a:xfrm>
+          <a:prstGeom prst="rect">
+            <a:avLst/>
+          </a:prstGeom>
+          <a:solidFill>
+            <a:srgbClr val="F0F4F8"/>
+          </a:solidFill>
+          <a:ln>
+            <a:solidFill>
+              <a:srgbClr val="102A43"/>
+            </a:solidFill>
+          </a:ln>
+        </p:spPr>
+        <p:style>
+          <a:lnRef idx="1">
+            <a:schemeClr val="accent1"/>
+          </a:lnRef>
+          <a:fillRef idx="3">
+            <a:schemeClr val="accent1"/>
+          </a:fillRef>
+          <a:effectRef idx="2">
+            <a:schemeClr val="accent1"/>
+          </a:effectRef>
+          <a:fontRef idx="minor">
+            <a:schemeClr val="lt1"/>
+          </a:fontRef>
+        </p:style>
+        <p:txBody>
+          <a:bodyPr rtlCol="0" anchor="ctr"/>
+          <a:lstStyle/>
+          <a:p>
+            <a:pPr algn="ctr"/>
+          </a:p>
+        </p:txBody>
+      </p:sp>
+      <p:sp>
+        <p:nvSpPr>
+          <p:cNvPr id="6" name="TextBox 5"/>
+          <p:cNvSpPr txBox="1"/>
+          <p:nvPr/>
+        </p:nvSpPr>
+        <p:spPr>
+          <a:xfrm>
+            <a:off x="640080" y="1463040"/>
+            <a:ext cx="10881360" cy="731520"/>
+          </a:xfrm>
+          <a:prstGeom prst="rect">
+            <a:avLst/>
+          </a:prstGeom>
+          <a:noFill/>
+        </p:spPr>
+        <p:txBody>
+          <a:bodyPr wrap="square">
+            <a:spAutoFit/>
+          </a:bodyPr>
+          <a:lstStyle/>
+          <a:p>
+            <a:pPr>
+              <a:defRPr sz="1600" b="1">
+                <a:solidFill>
+                  <a:srgbClr val="102A43"/>
+                </a:solidFill>
+              </a:defRPr>
+            </a:pPr>
+            <a:r>
+              <a:t>1. 防死循环逻辑 (表三)</a:t>
+            </a:r>
+          </a:p>
+          <a:p>
+            <a:pPr>
+              <a:spcBef>
+                <a:spcPts val="400"/>
+              </a:spcBef>
+              <a:defRPr sz="1300">
+                <a:solidFill>
+                  <a:srgbClr val="243B53"/>
+                </a:solidFill>
+              </a:defRPr>
+            </a:pPr>
+            <a:r>
+              <a:t>同一行中，父级「工程物料」严禁与子级「组件」完全相同，防止系统展开死循环。</a:t>
+            </a:r>
+          </a:p>
+        </p:txBody>
+      </p:sp>
+      <p:sp>
+        <p:nvSpPr>
+          <p:cNvPr id="7" name="Rectangle 6"/>
+          <p:cNvSpPr/>
+          <p:nvPr/>
+        </p:nvSpPr>
+        <p:spPr>
+          <a:xfrm>
+            <a:off x="457200" y="2286000"/>
+            <a:ext cx="11247120" cy="868680"/>
+          </a:xfrm>
+          <a:prstGeom prst="rect">
+            <a:avLst/>
+          </a:prstGeom>
+          <a:solidFill>
+            <a:srgbClr val="F0F4F8"/>
+          </a:solidFill>
+          <a:ln>
+            <a:solidFill>
+              <a:srgbClr val="102A43"/>
+            </a:solidFill>
+          </a:ln>
+        </p:spPr>
+        <p:style>
+          <a:lnRef idx="1">
+            <a:schemeClr val="accent1"/>
+          </a:lnRef>
+          <a:fillRef idx="3">
+            <a:schemeClr val="accent1"/>
+          </a:fillRef>
+          <a:effectRef idx="2">
+            <a:schemeClr val="accent1"/>
+          </a:effectRef>
+          <a:fontRef idx="minor">
+            <a:schemeClr val="lt1"/>
+          </a:fontRef>
+        </p:style>
+        <p:txBody>
+          <a:bodyPr rtlCol="0" anchor="ctr"/>
+          <a:lstStyle/>
+          <a:p>
+            <a:pPr algn="ctr"/>
+          </a:p>
+        </p:txBody>
+      </p:sp>
+      <p:sp>
+        <p:nvSpPr>
+          <p:cNvPr id="8" name="TextBox 7"/>
+          <p:cNvSpPr txBox="1"/>
+          <p:nvPr/>
+        </p:nvSpPr>
+        <p:spPr>
+          <a:xfrm>
+            <a:off x="640080" y="2377440"/>
+            <a:ext cx="10881360" cy="731520"/>
+          </a:xfrm>
+          <a:prstGeom prst="rect">
+            <a:avLst/>
+          </a:prstGeom>
+          <a:noFill/>
+        </p:spPr>
+        <p:txBody>
+          <a:bodyPr wrap="square">
+            <a:spAutoFit/>
+          </a:bodyPr>
+          <a:lstStyle/>
+          <a:p>
+            <a:pPr>
+              <a:defRPr sz="1600" b="1">
+                <a:solidFill>
+                  <a:srgbClr val="102A43"/>
+                </a:solidFill>
+              </a:defRPr>
+            </a:pPr>
+            <a:r>
+              <a:t>2. 净数量特殊逻辑 (表三)</a:t>
+            </a:r>
+          </a:p>
+          <a:p>
+            <a:pPr>
+              <a:spcBef>
+                <a:spcPts val="400"/>
+              </a:spcBef>
+              <a:defRPr sz="1300">
+                <a:solidFill>
+                  <a:srgbClr val="243B53"/>
+                </a:solidFill>
+              </a:defRPr>
+            </a:pPr>
+            <a:r>
+              <a:t>• 一般物料：净数量必须 &gt; 0。</a:t>
+            </a:r>
+            <a:br/>
+            <a:r>
+              <a:t>• **特例**：组件代码末尾为 FL 或 FLD 时，净数量**必须为负数** (如退料)。</a:t>
+            </a:r>
+          </a:p>
+        </p:txBody>
+      </p:sp>
+      <p:sp>
+        <p:nvSpPr>
+          <p:cNvPr id="9" name="Rectangle 8"/>
+          <p:cNvSpPr/>
+          <p:nvPr/>
+        </p:nvSpPr>
+        <p:spPr>
+          <a:xfrm>
+            <a:off x="457200" y="3200400"/>
+            <a:ext cx="11247120" cy="868680"/>
+          </a:xfrm>
+          <a:prstGeom prst="rect">
+            <a:avLst/>
+          </a:prstGeom>
+          <a:solidFill>
+            <a:srgbClr val="F0F4F8"/>
+          </a:solidFill>
+          <a:ln>
+            <a:solidFill>
+              <a:srgbClr val="102A43"/>
+            </a:solidFill>
+          </a:ln>
+        </p:spPr>
+        <p:style>
+          <a:lnRef idx="1">
+            <a:schemeClr val="accent1"/>
+          </a:lnRef>
+          <a:fillRef idx="3">
+            <a:schemeClr val="accent1"/>
+          </a:fillRef>
+          <a:effectRef idx="2">
+            <a:schemeClr val="accent1"/>
+          </a:effectRef>
+          <a:fontRef idx="minor">
+            <a:schemeClr val="lt1"/>
+          </a:fontRef>
+        </p:style>
+        <p:txBody>
+          <a:bodyPr rtlCol="0" anchor="ctr"/>
+          <a:lstStyle/>
+          <a:p>
+            <a:pPr algn="ctr"/>
+          </a:p>
+        </p:txBody>
+      </p:sp>
+      <p:sp>
+        <p:nvSpPr>
+          <p:cNvPr id="10" name="TextBox 9"/>
+          <p:cNvSpPr txBox="1"/>
+          <p:nvPr/>
+        </p:nvSpPr>
+        <p:spPr>
+          <a:xfrm>
+            <a:off x="640080" y="3291840"/>
+            <a:ext cx="10881360" cy="731520"/>
+          </a:xfrm>
+          <a:prstGeom prst="rect">
+            <a:avLst/>
+          </a:prstGeom>
+          <a:noFill/>
+        </p:spPr>
+        <p:txBody>
+          <a:bodyPr wrap="square">
+            <a:spAutoFit/>
+          </a:bodyPr>
+          <a:lstStyle/>
+          <a:p>
+            <a:pPr>
+              <a:defRPr sz="1600" b="1">
+                <a:solidFill>
+                  <a:srgbClr val="102A43"/>
+                </a:solidFill>
+              </a:defRPr>
+            </a:pPr>
+            <a:r>
+              <a:t>3. 防重复工序 (表四)</a:t>
+            </a:r>
+          </a:p>
+          <a:p>
+            <a:pPr>
+              <a:spcBef>
+                <a:spcPts val="400"/>
+              </a:spcBef>
+              <a:defRPr sz="1300">
+                <a:solidFill>
+                  <a:srgbClr val="243B53"/>
+                </a:solidFill>
+              </a:defRPr>
+            </a:pPr>
+            <a:r>
+              <a:t>同一个「制造物料」下，不允许存在重复的工序编号，确保工艺路线唯一。</a:t>
+            </a:r>
+          </a:p>
+        </p:txBody>
+      </p:sp>
+      <p:sp>
+        <p:nvSpPr>
+          <p:cNvPr id="11" name="Rectangle 10"/>
+          <p:cNvSpPr/>
+          <p:nvPr/>
+        </p:nvSpPr>
+        <p:spPr>
+          <a:xfrm>
+            <a:off x="457200" y="4114800"/>
+            <a:ext cx="11247120" cy="868680"/>
+          </a:xfrm>
+          <a:prstGeom prst="rect">
+            <a:avLst/>
+          </a:prstGeom>
+          <a:solidFill>
+            <a:srgbClr val="F0F4F8"/>
+          </a:solidFill>
+          <a:ln>
+            <a:solidFill>
+              <a:srgbClr val="102A43"/>
+            </a:solidFill>
+          </a:ln>
+        </p:spPr>
+        <p:style>
+          <a:lnRef idx="1">
+            <a:schemeClr val="accent1"/>
+          </a:lnRef>
+          <a:fillRef idx="3">
+            <a:schemeClr val="accent1"/>
+          </a:fillRef>
+          <a:effectRef idx="2">
+            <a:schemeClr val="accent1"/>
+          </a:effectRef>
+          <a:fontRef idx="minor">
+            <a:schemeClr val="lt1"/>
+          </a:fontRef>
+        </p:style>
+        <p:txBody>
+          <a:bodyPr rtlCol="0" anchor="ctr"/>
+          <a:lstStyle/>
+          <a:p>
+            <a:pPr algn="ctr"/>
+          </a:p>
+        </p:txBody>
+      </p:sp>
+      <p:sp>
+        <p:nvSpPr>
+          <p:cNvPr id="12" name="TextBox 11"/>
+          <p:cNvSpPr txBox="1"/>
+          <p:nvPr/>
+        </p:nvSpPr>
+        <p:spPr>
+          <a:xfrm>
+            <a:off x="640080" y="4206240"/>
+            <a:ext cx="10881360" cy="731520"/>
+          </a:xfrm>
+          <a:prstGeom prst="rect">
+            <a:avLst/>
+          </a:prstGeom>
+          <a:noFill/>
+        </p:spPr>
+        <p:txBody>
+          <a:bodyPr wrap="square">
+            <a:spAutoFit/>
+          </a:bodyPr>
+          <a:lstStyle/>
+          <a:p>
+            <a:pPr>
+              <a:defRPr sz="1600" b="1">
+                <a:solidFill>
+                  <a:srgbClr val="102A43"/>
+                </a:solidFill>
+              </a:defRPr>
+            </a:pPr>
+            <a:r>
+              <a:t>4. 废品率与生产周期限制</a:t>
+            </a:r>
+          </a:p>
+          <a:p>
+            <a:pPr>
+              <a:spcBef>
+                <a:spcPts val="400"/>
+              </a:spcBef>
+              <a:defRPr sz="1300">
+                <a:solidFill>
+                  <a:srgbClr val="243B53"/>
+                </a:solidFill>
+              </a:defRPr>
+            </a:pPr>
+            <a:r>
+              <a:t>• 表三废品率：禁止输入负数。</a:t>
+            </a:r>
+            <a:br/>
+            <a:r>
+              <a:t>• 表四生产周期：必须 &gt; 0。</a:t>
+            </a:r>
+          </a:p>
+        </p:txBody>
+      </p:sp>
+      <p:sp>
+        <p:nvSpPr>
+          <p:cNvPr id="13" name="Rectangle 12"/>
+          <p:cNvSpPr/>
+          <p:nvPr/>
+        </p:nvSpPr>
+        <p:spPr>
+          <a:xfrm>
+            <a:off x="457200" y="5029200"/>
+            <a:ext cx="11247120" cy="868680"/>
+          </a:xfrm>
+          <a:prstGeom prst="rect">
+            <a:avLst/>
+          </a:prstGeom>
+          <a:solidFill>
+            <a:srgbClr val="F0F4F8"/>
+          </a:solidFill>
+          <a:ln>
+            <a:solidFill>
+              <a:srgbClr val="102A43"/>
+            </a:solidFill>
+          </a:ln>
+        </p:spPr>
+        <p:style>
+          <a:lnRef idx="1">
+            <a:schemeClr val="accent1"/>
+          </a:lnRef>
+          <a:fillRef idx="3">
+            <a:schemeClr val="accent1"/>
+          </a:fillRef>
+          <a:effectRef idx="2">
+            <a:schemeClr val="accent1"/>
+          </a:effectRef>
+          <a:fontRef idx="minor">
+            <a:schemeClr val="lt1"/>
+          </a:fontRef>
+        </p:style>
+        <p:txBody>
+          <a:bodyPr rtlCol="0" anchor="ctr"/>
+          <a:lstStyle/>
+          <a:p>
+            <a:pPr algn="ctr"/>
+          </a:p>
+        </p:txBody>
+      </p:sp>
+      <p:sp>
+        <p:nvSpPr>
+          <p:cNvPr id="14" name="TextBox 13"/>
+          <p:cNvSpPr txBox="1"/>
+          <p:nvPr/>
+        </p:nvSpPr>
+        <p:spPr>
+          <a:xfrm>
+            <a:off x="640080" y="5120640"/>
+            <a:ext cx="10881360" cy="731520"/>
+          </a:xfrm>
+          <a:prstGeom prst="rect">
+            <a:avLst/>
+          </a:prstGeom>
+          <a:noFill/>
+        </p:spPr>
+        <p:txBody>
+          <a:bodyPr wrap="square">
+            <a:spAutoFit/>
+          </a:bodyPr>
+          <a:lstStyle/>
+          <a:p>
+            <a:pPr>
+              <a:defRPr sz="1600" b="1">
+                <a:solidFill>
+                  <a:srgbClr val="102A43"/>
+                </a:solidFill>
+              </a:defRPr>
+            </a:pPr>
+            <a:r>
+              <a:t>5. 表五数值范围强制</a:t>
+            </a:r>
+          </a:p>
+          <a:p>
+            <a:pPr>
+              <a:spcBef>
+                <a:spcPts val="400"/>
+              </a:spcBef>
+              <a:defRPr sz="1300">
+                <a:solidFill>
+                  <a:srgbClr val="243B53"/>
+                </a:solidFill>
+              </a:defRPr>
+            </a:pPr>
+            <a:r>
+              <a:t>• SPM、理论重量：必须 &gt; 0。</a:t>
+            </a:r>
+            <a:br/>
+            <a:r>
+              <a:t>• 回料百分比：必须在 0~100 之间。</a:t>
+            </a:r>
+            <a:br/>
+            <a:r>
+              <a:t>• 模穴数：必须是正整数 (1, 2...)。</a:t>
             </a:r>
           </a:p>
         </p:txBody>

</xml_diff>

<commit_message>
feat: 新增表三防重复、表二关联校验及表五重量逻辑 Co-authored-by: monkeycode-ai <monkeycode-ai@chaitin.com>
</commit_message>
<xml_diff>
--- a/BOM_校验规则详情汇总.pptx
+++ b/BOM_校验规则详情汇总.pptx
@@ -6899,7 +6899,7 @@
               </a:defRPr>
             </a:pPr>
             <a:r>
-              <a:t>5. 表五数值范围强制</a:t>
+              <a:t>5. 表五数值范围与逻辑</a:t>
             </a:r>
           </a:p>
           <a:p>
@@ -6922,7 +6922,201 @@
             </a:r>
             <a:br/>
             <a:r>
-              <a:t>• 模穴数：必须是正整数 (1, 2...)。</a:t>
+              <a:t>• 模穴数：必须是正整数。</a:t>
+            </a:r>
+            <a:br/>
+            <a:r>
+              <a:t>• **重量约束**：产品塑胶重量 不能超过 产品理论重量。</a:t>
+            </a:r>
+          </a:p>
+        </p:txBody>
+      </p:sp>
+      <p:sp>
+        <p:nvSpPr>
+          <p:cNvPr id="15" name="Rectangle 14"/>
+          <p:cNvSpPr/>
+          <p:nvPr/>
+        </p:nvSpPr>
+        <p:spPr>
+          <a:xfrm>
+            <a:off x="457200" y="5943600"/>
+            <a:ext cx="11247120" cy="868680"/>
+          </a:xfrm>
+          <a:prstGeom prst="rect">
+            <a:avLst/>
+          </a:prstGeom>
+          <a:solidFill>
+            <a:srgbClr val="F0F4F8"/>
+          </a:solidFill>
+          <a:ln>
+            <a:solidFill>
+              <a:srgbClr val="102A43"/>
+            </a:solidFill>
+          </a:ln>
+        </p:spPr>
+        <p:style>
+          <a:lnRef idx="1">
+            <a:schemeClr val="accent1"/>
+          </a:lnRef>
+          <a:fillRef idx="3">
+            <a:schemeClr val="accent1"/>
+          </a:fillRef>
+          <a:effectRef idx="2">
+            <a:schemeClr val="accent1"/>
+          </a:effectRef>
+          <a:fontRef idx="minor">
+            <a:schemeClr val="lt1"/>
+          </a:fontRef>
+        </p:style>
+        <p:txBody>
+          <a:bodyPr rtlCol="0" anchor="ctr"/>
+          <a:lstStyle/>
+          <a:p>
+            <a:pPr algn="ctr"/>
+          </a:p>
+        </p:txBody>
+      </p:sp>
+      <p:sp>
+        <p:nvSpPr>
+          <p:cNvPr id="16" name="TextBox 15"/>
+          <p:cNvSpPr txBox="1"/>
+          <p:nvPr/>
+        </p:nvSpPr>
+        <p:spPr>
+          <a:xfrm>
+            <a:off x="640080" y="6035040"/>
+            <a:ext cx="10881360" cy="731520"/>
+          </a:xfrm>
+          <a:prstGeom prst="rect">
+            <a:avLst/>
+          </a:prstGeom>
+          <a:noFill/>
+        </p:spPr>
+        <p:txBody>
+          <a:bodyPr wrap="square">
+            <a:spAutoFit/>
+          </a:bodyPr>
+          <a:lstStyle/>
+          <a:p>
+            <a:pPr>
+              <a:defRPr sz="1600" b="1">
+                <a:solidFill>
+                  <a:srgbClr val="102A43"/>
+                </a:solidFill>
+              </a:defRPr>
+            </a:pPr>
+            <a:r>
+              <a:t>6. 表二关联校验</a:t>
+            </a:r>
+          </a:p>
+          <a:p>
+            <a:pPr>
+              <a:spcBef>
+                <a:spcPts val="400"/>
+              </a:spcBef>
+              <a:defRPr sz="1300">
+                <a:solidFill>
+                  <a:srgbClr val="243B53"/>
+                </a:solidFill>
+              </a:defRPr>
+            </a:pPr>
+            <a:r>
+              <a:t>• 若填写了「业务伙伴物料代码」，则「客户代码」必须同时填写。</a:t>
+            </a:r>
+          </a:p>
+        </p:txBody>
+      </p:sp>
+      <p:sp>
+        <p:nvSpPr>
+          <p:cNvPr id="17" name="Rectangle 16"/>
+          <p:cNvSpPr/>
+          <p:nvPr/>
+        </p:nvSpPr>
+        <p:spPr>
+          <a:xfrm>
+            <a:off x="457200" y="6858000"/>
+            <a:ext cx="11247120" cy="868680"/>
+          </a:xfrm>
+          <a:prstGeom prst="rect">
+            <a:avLst/>
+          </a:prstGeom>
+          <a:solidFill>
+            <a:srgbClr val="F0F4F8"/>
+          </a:solidFill>
+          <a:ln>
+            <a:solidFill>
+              <a:srgbClr val="102A43"/>
+            </a:solidFill>
+          </a:ln>
+        </p:spPr>
+        <p:style>
+          <a:lnRef idx="1">
+            <a:schemeClr val="accent1"/>
+          </a:lnRef>
+          <a:fillRef idx="3">
+            <a:schemeClr val="accent1"/>
+          </a:fillRef>
+          <a:effectRef idx="2">
+            <a:schemeClr val="accent1"/>
+          </a:effectRef>
+          <a:fontRef idx="minor">
+            <a:schemeClr val="lt1"/>
+          </a:fontRef>
+        </p:style>
+        <p:txBody>
+          <a:bodyPr rtlCol="0" anchor="ctr"/>
+          <a:lstStyle/>
+          <a:p>
+            <a:pPr algn="ctr"/>
+          </a:p>
+        </p:txBody>
+      </p:sp>
+      <p:sp>
+        <p:nvSpPr>
+          <p:cNvPr id="18" name="TextBox 17"/>
+          <p:cNvSpPr txBox="1"/>
+          <p:nvPr/>
+        </p:nvSpPr>
+        <p:spPr>
+          <a:xfrm>
+            <a:off x="640080" y="6949440"/>
+            <a:ext cx="10881360" cy="731520"/>
+          </a:xfrm>
+          <a:prstGeom prst="rect">
+            <a:avLst/>
+          </a:prstGeom>
+          <a:noFill/>
+        </p:spPr>
+        <p:txBody>
+          <a:bodyPr wrap="square">
+            <a:spAutoFit/>
+          </a:bodyPr>
+          <a:lstStyle/>
+          <a:p>
+            <a:pPr>
+              <a:defRPr sz="1600" b="1">
+                <a:solidFill>
+                  <a:srgbClr val="102A43"/>
+                </a:solidFill>
+              </a:defRPr>
+            </a:pPr>
+            <a:r>
+              <a:t>7. 表三结构组合唯一性</a:t>
+            </a:r>
+          </a:p>
+          <a:p>
+            <a:pPr>
+              <a:spcBef>
+                <a:spcPts val="400"/>
+              </a:spcBef>
+              <a:defRPr sz="1300">
+                <a:solidFill>
+                  <a:srgbClr val="243B53"/>
+                </a:solidFill>
+              </a:defRPr>
+            </a:pPr>
+            <a:r>
+              <a:t>• BOM 结构中，「工程物料」与「组件」的配对该表中必须是唯一的，防止重复粘贴导致冗余。</a:t>
             </a:r>
           </a:p>
         </p:txBody>

</xml_diff>

<commit_message>
feat: 表四外协工艺与T4任务双向绑定校验 Co-authored-by: monkeycode-ai <monkeycode-ai@chaitin.com>
</commit_message>
<xml_diff>
--- a/BOM_校验规则详情汇总.pptx
+++ b/BOM_校验规则详情汇总.pptx
@@ -7220,6 +7220,105 @@
             <a:br/>
             <a:r>
               <a:t>• 表五：物料尾X → 产品理论重量免填。</a:t>
+            </a:r>
+          </a:p>
+        </p:txBody>
+      </p:sp>
+      <p:sp>
+        <p:nvSpPr>
+          <p:cNvPr id="21" name="Rectangle 20"/>
+          <p:cNvSpPr/>
+          <p:nvPr/>
+        </p:nvSpPr>
+        <p:spPr>
+          <a:xfrm>
+            <a:off x="457200" y="8686800"/>
+            <a:ext cx="11247120" cy="868680"/>
+          </a:xfrm>
+          <a:prstGeom prst="rect">
+            <a:avLst/>
+          </a:prstGeom>
+          <a:solidFill>
+            <a:srgbClr val="F0F4F8"/>
+          </a:solidFill>
+          <a:ln>
+            <a:solidFill>
+              <a:srgbClr val="102A43"/>
+            </a:solidFill>
+          </a:ln>
+        </p:spPr>
+        <p:style>
+          <a:lnRef idx="1">
+            <a:schemeClr val="accent1"/>
+          </a:lnRef>
+          <a:fillRef idx="3">
+            <a:schemeClr val="accent1"/>
+          </a:fillRef>
+          <a:effectRef idx="2">
+            <a:schemeClr val="accent1"/>
+          </a:effectRef>
+          <a:fontRef idx="minor">
+            <a:schemeClr val="lt1"/>
+          </a:fontRef>
+        </p:style>
+        <p:txBody>
+          <a:bodyPr rtlCol="0" anchor="ctr"/>
+          <a:lstStyle/>
+          <a:p>
+            <a:pPr algn="ctr"/>
+          </a:p>
+        </p:txBody>
+      </p:sp>
+      <p:sp>
+        <p:nvSpPr>
+          <p:cNvPr id="22" name="TextBox 21"/>
+          <p:cNvSpPr txBox="1"/>
+          <p:nvPr/>
+        </p:nvSpPr>
+        <p:spPr>
+          <a:xfrm>
+            <a:off x="640080" y="8778240"/>
+            <a:ext cx="10881360" cy="731520"/>
+          </a:xfrm>
+          <a:prstGeom prst="rect">
+            <a:avLst/>
+          </a:prstGeom>
+          <a:noFill/>
+        </p:spPr>
+        <p:txBody>
+          <a:bodyPr wrap="square">
+            <a:spAutoFit/>
+          </a:bodyPr>
+          <a:lstStyle/>
+          <a:p>
+            <a:pPr>
+              <a:defRPr sz="1600" b="1">
+                <a:solidFill>
+                  <a:srgbClr val="102A43"/>
+                </a:solidFill>
+              </a:defRPr>
+            </a:pPr>
+            <a:r>
+              <a:t>9. 表四外协工艺与T4任务绑定</a:t>
+            </a:r>
+          </a:p>
+          <a:p>
+            <a:pPr>
+              <a:spcBef>
+                <a:spcPts val="400"/>
+              </a:spcBef>
+              <a:defRPr sz="1300">
+                <a:solidFill>
+                  <a:srgbClr val="243B53"/>
+                </a:solidFill>
+              </a:defRPr>
+            </a:pPr>
+            <a:r>
+              <a:t>• 工艺流程说明含「外协」 ⇔ 任务前两位必须为 T4。</a:t>
+            </a:r>
+            <a:br/>
+            <a:r>
+              <a:t>• 仅满足一方而另一方不满足时均报错。</a:t>
             </a:r>
           </a:p>
         </p:txBody>

</xml_diff>

<commit_message>
fix: 外协/X类免填条件从「尾字母X」修正为「含-X」字符串匹配 Co-authored-by: monkeycode-ai <monkeycode-ai@chaitin.com>
</commit_message>
<xml_diff>
--- a/BOM_校验规则详情汇总.pptx
+++ b/BOM_校验规则详情汇总.pptx
@@ -7211,15 +7211,15 @@
               </a:defRPr>
             </a:pPr>
             <a:r>
-              <a:t>• 表二：物料名称含「外协」或物料号尾X → 保质期/呆滞期免填。</a:t>
+              <a:t>• 表二：物料名称含「外协」或物料号含 -X → 保质期/呆滞期免填。</a:t>
             </a:r>
             <a:br/>
             <a:r>
-              <a:t>• 表四：制造物料含「外协」或尾X → 机器免填。</a:t>
+              <a:t>• 表四：制造物料含「外协」或含 -X → 机器免填。</a:t>
             </a:r>
             <a:br/>
             <a:r>
-              <a:t>• 表五：物料尾X → 产品理论重量免填。</a:t>
+              <a:t>• 表五：物料含 -X → 产品理论重量免填。</a:t>
             </a:r>
           </a:p>
         </p:txBody>

</xml_diff>